<commit_message>
Presentation: re-render with hybrid lab template
The supplied lab_template.pptx had a duplicate 'Title and Content'
layout name and was missing several Pandoc-required layouts
(Comparison, Content with Caption, Blank), causing Pandoc to fail
with 'Could not find a 0th placeholder of type obj'.

Worked around by replacing lab_template.pptx with a hybrid: Pandoc's
default reference.pptx scaffold + theme1.xml from the original
template. Colors and font scheme are inherited from the lab brand;
master logo and custom shape placements are not.

Co-Authored-By: Claude Opus 4.7 (1M context) <noreply@anthropic.com>
</commit_message>
<xml_diff>
--- a/reports/cleanTMLE_presentation.pptx
+++ b/reports/cleanTMLE_presentation.pptx
@@ -7858,116 +7858,56 @@
 </file>
 
 <file path=ppt/theme/theme1.xml><?xml version="1.0" encoding="utf-8"?>
-<a:theme xmlns:a="http://schemas.openxmlformats.org/drawingml/2006/main" name="Office Theme">
+<a:theme xmlns:a="http://schemas.openxmlformats.org/drawingml/2006/main" name="BMGF_ki_Theme_v002">
   <a:themeElements>
-    <a:clrScheme name="Office">
+    <a:clrScheme name="HBGDki_color_v1">
       <a:dk1>
-        <a:sysClr val="windowText" lastClr="000000"/>
+        <a:srgbClr val="343131"/>
       </a:dk1>
       <a:lt1>
-        <a:sysClr val="window" lastClr="FFFFFF"/>
+        <a:srgbClr val="FFFFFF"/>
       </a:lt1>
       <a:dk2>
-        <a:srgbClr val="1F497D"/>
+        <a:srgbClr val="9B242D"/>
       </a:dk2>
       <a:lt2>
-        <a:srgbClr val="EEECE1"/>
+        <a:srgbClr val="FFFFFF"/>
       </a:lt2>
       <a:accent1>
-        <a:srgbClr val="4F81BD"/>
+        <a:srgbClr val="3086AB"/>
       </a:accent1>
       <a:accent2>
-        <a:srgbClr val="C0504D"/>
+        <a:srgbClr val="E67021"/>
       </a:accent2>
       <a:accent3>
-        <a:srgbClr val="9BBB59"/>
+        <a:srgbClr val="F29B0E"/>
       </a:accent3>
       <a:accent4>
-        <a:srgbClr val="8064A2"/>
+        <a:srgbClr val="B51F29"/>
       </a:accent4>
       <a:accent5>
-        <a:srgbClr val="4BACC6"/>
+        <a:srgbClr val="823B69"/>
       </a:accent5>
       <a:accent6>
-        <a:srgbClr val="F79646"/>
+        <a:srgbClr val="AAA092"/>
       </a:accent6>
       <a:hlink>
-        <a:srgbClr val="0000FF"/>
+        <a:srgbClr val="3086AB"/>
       </a:hlink>
       <a:folHlink>
-        <a:srgbClr val="800080"/>
+        <a:srgbClr val="823B69"/>
       </a:folHlink>
     </a:clrScheme>
-    <a:fontScheme name="Office">
+    <a:fontScheme name="Foundation PPT Fonts - Jan 2014">
       <a:majorFont>
-        <a:latin typeface="Calibri"/>
+        <a:latin typeface="Arial"/>
         <a:ea typeface=""/>
         <a:cs typeface=""/>
-        <a:font script="Jpan" typeface="ＭＳ Ｐゴシック"/>
-        <a:font script="Hang" typeface="맑은 고딕"/>
-        <a:font script="Hans" typeface="宋体"/>
-        <a:font script="Hant" typeface="新細明體"/>
-        <a:font script="Arab" typeface="Times New Roman"/>
-        <a:font script="Hebr" typeface="Times New Roman"/>
-        <a:font script="Thai" typeface="Angsana New"/>
-        <a:font script="Ethi" typeface="Nyala"/>
-        <a:font script="Beng" typeface="Vrinda"/>
-        <a:font script="Gujr" typeface="Shruti"/>
-        <a:font script="Khmr" typeface="MoolBoran"/>
-        <a:font script="Knda" typeface="Tunga"/>
-        <a:font script="Guru" typeface="Raavi"/>
-        <a:font script="Cans" typeface="Euphemia"/>
-        <a:font script="Cher" typeface="Plantagenet Cherokee"/>
-        <a:font script="Yiii" typeface="Microsoft Yi Baiti"/>
-        <a:font script="Tibt" typeface="Microsoft Himalaya"/>
-        <a:font script="Thaa" typeface="MV Boli"/>
-        <a:font script="Deva" typeface="Mangal"/>
-        <a:font script="Telu" typeface="Gautami"/>
-        <a:font script="Taml" typeface="Latha"/>
-        <a:font script="Syrc" typeface="Estrangelo Edessa"/>
-        <a:font script="Orya" typeface="Kalinga"/>
-        <a:font script="Mlym" typeface="Kartika"/>
-        <a:font script="Laoo" typeface="DokChampa"/>
-        <a:font script="Sinh" typeface="Iskoola Pota"/>
-        <a:font script="Mong" typeface="Mongolian Baiti"/>
-        <a:font script="Viet" typeface="Times New Roman"/>
-        <a:font script="Uigh" typeface="Microsoft Uighur"/>
-        <a:font script="Geor" typeface="Sylfaen"/>
       </a:majorFont>
       <a:minorFont>
-        <a:latin typeface="Calibri"/>
+        <a:latin typeface="Arial"/>
         <a:ea typeface=""/>
         <a:cs typeface=""/>
-        <a:font script="Jpan" typeface="ＭＳ Ｐゴシック"/>
-        <a:font script="Hang" typeface="맑은 고딕"/>
-        <a:font script="Hans" typeface="宋体"/>
-        <a:font script="Hant" typeface="新細明體"/>
-        <a:font script="Arab" typeface="Arial"/>
-        <a:font script="Hebr" typeface="Arial"/>
-        <a:font script="Thai" typeface="Cordia New"/>
-        <a:font script="Ethi" typeface="Nyala"/>
-        <a:font script="Beng" typeface="Vrinda"/>
-        <a:font script="Gujr" typeface="Shruti"/>
-        <a:font script="Khmr" typeface="DaunPenh"/>
-        <a:font script="Knda" typeface="Tunga"/>
-        <a:font script="Guru" typeface="Raavi"/>
-        <a:font script="Cans" typeface="Euphemia"/>
-        <a:font script="Cher" typeface="Plantagenet Cherokee"/>
-        <a:font script="Yiii" typeface="Microsoft Yi Baiti"/>
-        <a:font script="Tibt" typeface="Microsoft Himalaya"/>
-        <a:font script="Thaa" typeface="MV Boli"/>
-        <a:font script="Deva" typeface="Mangal"/>
-        <a:font script="Telu" typeface="Gautami"/>
-        <a:font script="Taml" typeface="Latha"/>
-        <a:font script="Syrc" typeface="Estrangelo Edessa"/>
-        <a:font script="Orya" typeface="Kalinga"/>
-        <a:font script="Mlym" typeface="Kartika"/>
-        <a:font script="Laoo" typeface="DokChampa"/>
-        <a:font script="Sinh" typeface="Iskoola Pota"/>
-        <a:font script="Mong" typeface="Mongolian Baiti"/>
-        <a:font script="Viet" typeface="Arial"/>
-        <a:font script="Uigh" typeface="Microsoft Uighur"/>
-        <a:font script="Geor" typeface="Sylfaen"/>
       </a:minorFont>
     </a:fontScheme>
     <a:fmtScheme name="Office">
@@ -8002,16 +7942,20 @@
           <a:gsLst>
             <a:gs pos="0">
               <a:schemeClr val="phClr">
-                <a:tint val="100000"/>
-                <a:shade val="100000"/>
+                <a:shade val="51000"/>
+                <a:satMod val="130000"/>
+              </a:schemeClr>
+            </a:gs>
+            <a:gs pos="80000">
+              <a:schemeClr val="phClr">
+                <a:shade val="93000"/>
                 <a:satMod val="130000"/>
               </a:schemeClr>
             </a:gs>
             <a:gs pos="100000">
               <a:schemeClr val="phClr">
-                <a:tint val="50000"/>
-                <a:shade val="100000"/>
-                <a:satMod val="350000"/>
+                <a:shade val="94000"/>
+                <a:satMod val="135000"/>
               </a:schemeClr>
             </a:gs>
           </a:gsLst>
@@ -8135,17 +8079,27 @@
   </a:themeElements>
   <a:objectDefaults>
     <a:spDef>
-      <a:spPr/>
-      <a:bodyPr/>
-      <a:lstStyle/>
+      <a:spPr>
+        <a:ln>
+          <a:noFill/>
+        </a:ln>
+      </a:spPr>
+      <a:bodyPr rtlCol="0" anchor="ctr"/>
+      <a:lstStyle>
+        <a:defPPr algn="ctr">
+          <a:defRPr/>
+        </a:defPPr>
+      </a:lstStyle>
       <a:style>
-        <a:lnRef idx="1">
-          <a:schemeClr val="accent1"/>
+        <a:lnRef idx="2">
+          <a:schemeClr val="accent1">
+            <a:shade val="50000"/>
+          </a:schemeClr>
         </a:lnRef>
-        <a:fillRef idx="3">
+        <a:fillRef idx="1">
           <a:schemeClr val="accent1"/>
         </a:fillRef>
-        <a:effectRef idx="2">
+        <a:effectRef idx="0">
           <a:schemeClr val="accent1"/>
         </a:effectRef>
         <a:fontRef idx="minor">
@@ -8153,27 +8107,29 @@
         </a:fontRef>
       </a:style>
     </a:spDef>
-    <a:lnDef>
-      <a:spPr/>
-      <a:bodyPr/>
-      <a:lstStyle/>
-      <a:style>
-        <a:lnRef idx="2">
-          <a:schemeClr val="accent1"/>
-        </a:lnRef>
-        <a:fillRef idx="0">
-          <a:schemeClr val="accent1"/>
-        </a:fillRef>
-        <a:effectRef idx="1">
-          <a:schemeClr val="accent1"/>
-        </a:effectRef>
-        <a:fontRef idx="minor">
-          <a:schemeClr val="tx1"/>
-        </a:fontRef>
-      </a:style>
-    </a:lnDef>
+    <a:txDef>
+      <a:spPr>
+        <a:noFill/>
+      </a:spPr>
+      <a:bodyPr wrap="none" lIns="0" tIns="0" rIns="0" bIns="0" rtlCol="0">
+        <a:spAutoFit/>
+      </a:bodyPr>
+      <a:lstStyle>
+        <a:defPPr algn="ctr">
+          <a:defRPr sz="1000" dirty="0" smtClean="0">
+            <a:latin typeface="Arial" pitchFamily="34" charset="0"/>
+            <a:cs typeface="Arial" pitchFamily="34" charset="0"/>
+          </a:defRPr>
+        </a:defPPr>
+      </a:lstStyle>
+    </a:txDef>
   </a:objectDefaults>
   <a:extraClrSchemeLst/>
+  <a:extLst>
+    <a:ext uri="{05A4C25C-085E-4340-85A3-A5531E510DB2}">
+      <thm15:themeFamily xmlns:thm15="http://schemas.microsoft.com/office/thememl/2012/main" name="BMGF_ki_Theme_v002" id="{246C18AA-3F48-4B76-BAE8-BB32034B1366}" vid="{791D82C9-73BB-4286-B133-6928F9479036}"/>
+    </a:ext>
+  </a:extLst>
 </a:theme>
 </file>
 

</xml_diff>

<commit_message>
Reduce slide-text size: shrink sz attributes in master/layouts/theme by 30% (8pt floor); re-render
</commit_message>
<xml_diff>
--- a/reports/cleanTMLE_presentation.pptx
+++ b/reports/cleanTMLE_presentation.pptx
@@ -1014,7 +1014,7 @@
           <a:bodyPr anchor="t"/>
           <a:lstStyle>
             <a:lvl1pPr algn="l">
-              <a:defRPr sz="3000" b="1" cap="all"/>
+              <a:defRPr sz="2100" b="1" cap="all"/>
             </a:lvl1pPr>
           </a:lstStyle>
           <a:p>
@@ -1046,7 +1046,7 @@
           <a:lstStyle>
             <a:lvl1pPr marL="0" indent="0">
               <a:buNone/>
-              <a:defRPr sz="1500">
+              <a:defRPr sz="1050">
                 <a:solidFill>
                   <a:schemeClr val="tx1">
                     <a:tint val="75000"/>
@@ -1056,7 +1056,7 @@
             </a:lvl1pPr>
             <a:lvl2pPr marL="342900" indent="0">
               <a:buNone/>
-              <a:defRPr sz="1350">
+              <a:defRPr sz="944">
                 <a:solidFill>
                   <a:schemeClr val="tx1">
                     <a:tint val="75000"/>
@@ -1066,7 +1066,7 @@
             </a:lvl2pPr>
             <a:lvl3pPr marL="685800" indent="0">
               <a:buNone/>
-              <a:defRPr sz="1200">
+              <a:defRPr sz="840">
                 <a:solidFill>
                   <a:schemeClr val="tx1">
                     <a:tint val="75000"/>
@@ -1076,7 +1076,7 @@
             </a:lvl3pPr>
             <a:lvl4pPr marL="1028700" indent="0">
               <a:buNone/>
-              <a:defRPr sz="1050">
+              <a:defRPr sz="800">
                 <a:solidFill>
                   <a:schemeClr val="tx1">
                     <a:tint val="75000"/>
@@ -1086,7 +1086,7 @@
             </a:lvl4pPr>
             <a:lvl5pPr marL="1371600" indent="0">
               <a:buNone/>
-              <a:defRPr sz="1050">
+              <a:defRPr sz="800">
                 <a:solidFill>
                   <a:schemeClr val="tx1">
                     <a:tint val="75000"/>
@@ -1096,7 +1096,7 @@
             </a:lvl5pPr>
             <a:lvl6pPr marL="1714500" indent="0">
               <a:buNone/>
-              <a:defRPr sz="1050">
+              <a:defRPr sz="800">
                 <a:solidFill>
                   <a:schemeClr val="tx1">
                     <a:tint val="75000"/>
@@ -1106,7 +1106,7 @@
             </a:lvl6pPr>
             <a:lvl7pPr marL="2057400" indent="0">
               <a:buNone/>
-              <a:defRPr sz="1050">
+              <a:defRPr sz="800">
                 <a:solidFill>
                   <a:schemeClr val="tx1">
                     <a:tint val="75000"/>
@@ -1116,7 +1116,7 @@
             </a:lvl7pPr>
             <a:lvl8pPr marL="2400300" indent="0">
               <a:buNone/>
-              <a:defRPr sz="1050">
+              <a:defRPr sz="800">
                 <a:solidFill>
                   <a:schemeClr val="tx1">
                     <a:tint val="75000"/>
@@ -1126,7 +1126,7 @@
             </a:lvl8pPr>
             <a:lvl9pPr marL="2743200" indent="0">
               <a:buNone/>
-              <a:defRPr sz="1050">
+              <a:defRPr sz="800">
                 <a:solidFill>
                   <a:schemeClr val="tx1">
                     <a:tint val="75000"/>
@@ -1281,31 +1281,31 @@
           <a:bodyPr/>
           <a:lstStyle>
             <a:lvl1pPr>
-              <a:defRPr sz="2100"/>
+              <a:defRPr sz="1470"/>
             </a:lvl1pPr>
             <a:lvl2pPr>
-              <a:defRPr sz="1800"/>
+              <a:defRPr sz="1260"/>
             </a:lvl2pPr>
             <a:lvl3pPr>
-              <a:defRPr sz="1500"/>
+              <a:defRPr sz="1050"/>
             </a:lvl3pPr>
             <a:lvl4pPr>
-              <a:defRPr sz="1350"/>
+              <a:defRPr sz="944"/>
             </a:lvl4pPr>
             <a:lvl5pPr>
-              <a:defRPr sz="1350"/>
+              <a:defRPr sz="944"/>
             </a:lvl5pPr>
             <a:lvl6pPr>
-              <a:defRPr sz="1350"/>
+              <a:defRPr sz="944"/>
             </a:lvl6pPr>
             <a:lvl7pPr>
-              <a:defRPr sz="1350"/>
+              <a:defRPr sz="944"/>
             </a:lvl7pPr>
             <a:lvl8pPr>
-              <a:defRPr sz="1350"/>
+              <a:defRPr sz="944"/>
             </a:lvl8pPr>
             <a:lvl9pPr>
-              <a:defRPr sz="1350"/>
+              <a:defRPr sz="944"/>
             </a:lvl9pPr>
           </a:lstStyle>
           <a:p>
@@ -1365,31 +1365,31 @@
           <a:bodyPr/>
           <a:lstStyle>
             <a:lvl1pPr>
-              <a:defRPr sz="2100"/>
+              <a:defRPr sz="1470"/>
             </a:lvl1pPr>
             <a:lvl2pPr>
-              <a:defRPr sz="1800"/>
+              <a:defRPr sz="1260"/>
             </a:lvl2pPr>
             <a:lvl3pPr>
-              <a:defRPr sz="1500"/>
+              <a:defRPr sz="1050"/>
             </a:lvl3pPr>
             <a:lvl4pPr>
-              <a:defRPr sz="1350"/>
+              <a:defRPr sz="944"/>
             </a:lvl4pPr>
             <a:lvl5pPr>
-              <a:defRPr sz="1350"/>
+              <a:defRPr sz="944"/>
             </a:lvl5pPr>
             <a:lvl6pPr>
-              <a:defRPr sz="1350"/>
+              <a:defRPr sz="944"/>
             </a:lvl6pPr>
             <a:lvl7pPr>
-              <a:defRPr sz="1350"/>
+              <a:defRPr sz="944"/>
             </a:lvl7pPr>
             <a:lvl8pPr>
-              <a:defRPr sz="1350"/>
+              <a:defRPr sz="944"/>
             </a:lvl8pPr>
             <a:lvl9pPr>
-              <a:defRPr sz="1350"/>
+              <a:defRPr sz="944"/>
             </a:lvl9pPr>
           </a:lstStyle>
           <a:p>
@@ -1571,39 +1571,39 @@
           <a:lstStyle>
             <a:lvl1pPr marL="0" indent="0">
               <a:buNone/>
-              <a:defRPr sz="1800" b="1"/>
+              <a:defRPr sz="1260" b="1"/>
             </a:lvl1pPr>
             <a:lvl2pPr marL="342900" indent="0">
               <a:buNone/>
-              <a:defRPr sz="1500" b="1"/>
+              <a:defRPr sz="1050" b="1"/>
             </a:lvl2pPr>
             <a:lvl3pPr marL="685800" indent="0">
               <a:buNone/>
-              <a:defRPr sz="1350" b="1"/>
+              <a:defRPr sz="944" b="1"/>
             </a:lvl3pPr>
             <a:lvl4pPr marL="1028700" indent="0">
               <a:buNone/>
-              <a:defRPr sz="1200" b="1"/>
+              <a:defRPr sz="840" b="1"/>
             </a:lvl4pPr>
             <a:lvl5pPr marL="1371600" indent="0">
               <a:buNone/>
-              <a:defRPr sz="1200" b="1"/>
+              <a:defRPr sz="840" b="1"/>
             </a:lvl5pPr>
             <a:lvl6pPr marL="1714500" indent="0">
               <a:buNone/>
-              <a:defRPr sz="1200" b="1"/>
+              <a:defRPr sz="840" b="1"/>
             </a:lvl6pPr>
             <a:lvl7pPr marL="2057400" indent="0">
               <a:buNone/>
-              <a:defRPr sz="1200" b="1"/>
+              <a:defRPr sz="840" b="1"/>
             </a:lvl7pPr>
             <a:lvl8pPr marL="2400300" indent="0">
               <a:buNone/>
-              <a:defRPr sz="1200" b="1"/>
+              <a:defRPr sz="840" b="1"/>
             </a:lvl8pPr>
             <a:lvl9pPr marL="2743200" indent="0">
               <a:buNone/>
-              <a:defRPr sz="1200" b="1"/>
+              <a:defRPr sz="840" b="1"/>
             </a:lvl9pPr>
           </a:lstStyle>
           <a:p>
@@ -1635,31 +1635,31 @@
           <a:bodyPr/>
           <a:lstStyle>
             <a:lvl1pPr>
-              <a:defRPr sz="1800"/>
+              <a:defRPr sz="1260"/>
             </a:lvl1pPr>
             <a:lvl2pPr>
-              <a:defRPr sz="1500"/>
+              <a:defRPr sz="1050"/>
             </a:lvl2pPr>
             <a:lvl3pPr>
-              <a:defRPr sz="1350"/>
+              <a:defRPr sz="944"/>
             </a:lvl3pPr>
             <a:lvl4pPr>
-              <a:defRPr sz="1200"/>
+              <a:defRPr sz="840"/>
             </a:lvl4pPr>
             <a:lvl5pPr>
-              <a:defRPr sz="1200"/>
+              <a:defRPr sz="840"/>
             </a:lvl5pPr>
             <a:lvl6pPr>
-              <a:defRPr sz="1200"/>
+              <a:defRPr sz="840"/>
             </a:lvl6pPr>
             <a:lvl7pPr>
-              <a:defRPr sz="1200"/>
+              <a:defRPr sz="840"/>
             </a:lvl7pPr>
             <a:lvl8pPr>
-              <a:defRPr sz="1200"/>
+              <a:defRPr sz="840"/>
             </a:lvl8pPr>
             <a:lvl9pPr>
-              <a:defRPr sz="1200"/>
+              <a:defRPr sz="840"/>
             </a:lvl9pPr>
           </a:lstStyle>
           <a:p>
@@ -1720,39 +1720,39 @@
           <a:lstStyle>
             <a:lvl1pPr marL="0" indent="0">
               <a:buNone/>
-              <a:defRPr sz="1800" b="1"/>
+              <a:defRPr sz="1260" b="1"/>
             </a:lvl1pPr>
             <a:lvl2pPr marL="342900" indent="0">
               <a:buNone/>
-              <a:defRPr sz="1500" b="1"/>
+              <a:defRPr sz="1050" b="1"/>
             </a:lvl2pPr>
             <a:lvl3pPr marL="685800" indent="0">
               <a:buNone/>
-              <a:defRPr sz="1350" b="1"/>
+              <a:defRPr sz="944" b="1"/>
             </a:lvl3pPr>
             <a:lvl4pPr marL="1028700" indent="0">
               <a:buNone/>
-              <a:defRPr sz="1200" b="1"/>
+              <a:defRPr sz="840" b="1"/>
             </a:lvl4pPr>
             <a:lvl5pPr marL="1371600" indent="0">
               <a:buNone/>
-              <a:defRPr sz="1200" b="1"/>
+              <a:defRPr sz="840" b="1"/>
             </a:lvl5pPr>
             <a:lvl6pPr marL="1714500" indent="0">
               <a:buNone/>
-              <a:defRPr sz="1200" b="1"/>
+              <a:defRPr sz="840" b="1"/>
             </a:lvl6pPr>
             <a:lvl7pPr marL="2057400" indent="0">
               <a:buNone/>
-              <a:defRPr sz="1200" b="1"/>
+              <a:defRPr sz="840" b="1"/>
             </a:lvl7pPr>
             <a:lvl8pPr marL="2400300" indent="0">
               <a:buNone/>
-              <a:defRPr sz="1200" b="1"/>
+              <a:defRPr sz="840" b="1"/>
             </a:lvl8pPr>
             <a:lvl9pPr marL="2743200" indent="0">
               <a:buNone/>
-              <a:defRPr sz="1200" b="1"/>
+              <a:defRPr sz="840" b="1"/>
             </a:lvl9pPr>
           </a:lstStyle>
           <a:p>
@@ -1784,31 +1784,31 @@
           <a:bodyPr/>
           <a:lstStyle>
             <a:lvl1pPr>
-              <a:defRPr sz="1800"/>
+              <a:defRPr sz="1260"/>
             </a:lvl1pPr>
             <a:lvl2pPr>
-              <a:defRPr sz="1500"/>
+              <a:defRPr sz="1050"/>
             </a:lvl2pPr>
             <a:lvl3pPr>
-              <a:defRPr sz="1350"/>
+              <a:defRPr sz="944"/>
             </a:lvl3pPr>
             <a:lvl4pPr>
-              <a:defRPr sz="1200"/>
+              <a:defRPr sz="840"/>
             </a:lvl4pPr>
             <a:lvl5pPr>
-              <a:defRPr sz="1200"/>
+              <a:defRPr sz="840"/>
             </a:lvl5pPr>
             <a:lvl6pPr>
-              <a:defRPr sz="1200"/>
+              <a:defRPr sz="840"/>
             </a:lvl6pPr>
             <a:lvl7pPr>
-              <a:defRPr sz="1200"/>
+              <a:defRPr sz="840"/>
             </a:lvl7pPr>
             <a:lvl8pPr>
-              <a:defRPr sz="1200"/>
+              <a:defRPr sz="840"/>
             </a:lvl8pPr>
             <a:lvl9pPr>
-              <a:defRPr sz="1200"/>
+              <a:defRPr sz="840"/>
             </a:lvl9pPr>
           </a:lstStyle>
           <a:p>
@@ -2175,7 +2175,7 @@
           <a:bodyPr anchor="b"/>
           <a:lstStyle>
             <a:lvl1pPr algn="l">
-              <a:defRPr sz="1500" b="1"/>
+              <a:defRPr sz="1050" b="1"/>
             </a:lvl1pPr>
           </a:lstStyle>
           <a:p>
@@ -2206,31 +2206,31 @@
           <a:bodyPr/>
           <a:lstStyle>
             <a:lvl1pPr>
-              <a:defRPr sz="2400"/>
+              <a:defRPr sz="1680"/>
             </a:lvl1pPr>
             <a:lvl2pPr>
-              <a:defRPr sz="2100"/>
+              <a:defRPr sz="1470"/>
             </a:lvl2pPr>
             <a:lvl3pPr>
-              <a:defRPr sz="1800"/>
+              <a:defRPr sz="1260"/>
             </a:lvl3pPr>
             <a:lvl4pPr>
-              <a:defRPr sz="1500"/>
+              <a:defRPr sz="1050"/>
             </a:lvl4pPr>
             <a:lvl5pPr>
-              <a:defRPr sz="1500"/>
+              <a:defRPr sz="1050"/>
             </a:lvl5pPr>
             <a:lvl6pPr>
-              <a:defRPr sz="1500"/>
+              <a:defRPr sz="1050"/>
             </a:lvl6pPr>
             <a:lvl7pPr>
-              <a:defRPr sz="1500"/>
+              <a:defRPr sz="1050"/>
             </a:lvl7pPr>
             <a:lvl8pPr>
-              <a:defRPr sz="1500"/>
+              <a:defRPr sz="1050"/>
             </a:lvl8pPr>
             <a:lvl9pPr>
-              <a:defRPr sz="1500"/>
+              <a:defRPr sz="1050"/>
             </a:lvl9pPr>
           </a:lstStyle>
           <a:p>
@@ -2291,39 +2291,39 @@
           <a:lstStyle>
             <a:lvl1pPr marL="0" indent="0">
               <a:buNone/>
-              <a:defRPr sz="1050"/>
+              <a:defRPr sz="800"/>
             </a:lvl1pPr>
             <a:lvl2pPr marL="342900" indent="0">
               <a:buNone/>
-              <a:defRPr sz="900"/>
+              <a:defRPr sz="800"/>
             </a:lvl2pPr>
             <a:lvl3pPr marL="685800" indent="0">
               <a:buNone/>
-              <a:defRPr sz="750"/>
+              <a:defRPr sz="800"/>
             </a:lvl3pPr>
             <a:lvl4pPr marL="1028700" indent="0">
               <a:buNone/>
-              <a:defRPr sz="675"/>
+              <a:defRPr sz="800"/>
             </a:lvl4pPr>
             <a:lvl5pPr marL="1371600" indent="0">
               <a:buNone/>
-              <a:defRPr sz="675"/>
+              <a:defRPr sz="800"/>
             </a:lvl5pPr>
             <a:lvl6pPr marL="1714500" indent="0">
               <a:buNone/>
-              <a:defRPr sz="675"/>
+              <a:defRPr sz="800"/>
             </a:lvl6pPr>
             <a:lvl7pPr marL="2057400" indent="0">
               <a:buNone/>
-              <a:defRPr sz="675"/>
+              <a:defRPr sz="800"/>
             </a:lvl7pPr>
             <a:lvl8pPr marL="2400300" indent="0">
               <a:buNone/>
-              <a:defRPr sz="675"/>
+              <a:defRPr sz="800"/>
             </a:lvl8pPr>
             <a:lvl9pPr marL="2743200" indent="0">
               <a:buNone/>
-              <a:defRPr sz="675"/>
+              <a:defRPr sz="800"/>
             </a:lvl9pPr>
           </a:lstStyle>
           <a:p>
@@ -2450,7 +2450,7 @@
           <a:bodyPr anchor="b"/>
           <a:lstStyle>
             <a:lvl1pPr algn="l">
-              <a:defRPr sz="1500" b="1"/>
+              <a:defRPr sz="1050" b="1"/>
             </a:lvl1pPr>
           </a:lstStyle>
           <a:p>
@@ -2482,39 +2482,39 @@
           <a:lstStyle>
             <a:lvl1pPr marL="0" indent="0">
               <a:buNone/>
-              <a:defRPr sz="2400"/>
+              <a:defRPr sz="1680"/>
             </a:lvl1pPr>
             <a:lvl2pPr marL="342900" indent="0">
               <a:buNone/>
-              <a:defRPr sz="2100"/>
+              <a:defRPr sz="1470"/>
             </a:lvl2pPr>
             <a:lvl3pPr marL="685800" indent="0">
               <a:buNone/>
-              <a:defRPr sz="1800"/>
+              <a:defRPr sz="1260"/>
             </a:lvl3pPr>
             <a:lvl4pPr marL="1028700" indent="0">
               <a:buNone/>
-              <a:defRPr sz="1500"/>
+              <a:defRPr sz="1050"/>
             </a:lvl4pPr>
             <a:lvl5pPr marL="1371600" indent="0">
               <a:buNone/>
-              <a:defRPr sz="1500"/>
+              <a:defRPr sz="1050"/>
             </a:lvl5pPr>
             <a:lvl6pPr marL="1714500" indent="0">
               <a:buNone/>
-              <a:defRPr sz="1500"/>
+              <a:defRPr sz="1050"/>
             </a:lvl6pPr>
             <a:lvl7pPr marL="2057400" indent="0">
               <a:buNone/>
-              <a:defRPr sz="1500"/>
+              <a:defRPr sz="1050"/>
             </a:lvl7pPr>
             <a:lvl8pPr marL="2400300" indent="0">
               <a:buNone/>
-              <a:defRPr sz="1500"/>
+              <a:defRPr sz="1050"/>
             </a:lvl8pPr>
             <a:lvl9pPr marL="2743200" indent="0">
               <a:buNone/>
-              <a:defRPr sz="1500"/>
+              <a:defRPr sz="1050"/>
             </a:lvl9pPr>
           </a:lstStyle>
           <a:p>
@@ -2543,39 +2543,39 @@
           <a:lstStyle>
             <a:lvl1pPr marL="0" indent="0">
               <a:buNone/>
-              <a:defRPr sz="1050"/>
+              <a:defRPr sz="800"/>
             </a:lvl1pPr>
             <a:lvl2pPr marL="342900" indent="0">
               <a:buNone/>
-              <a:defRPr sz="900"/>
+              <a:defRPr sz="800"/>
             </a:lvl2pPr>
             <a:lvl3pPr marL="685800" indent="0">
               <a:buNone/>
-              <a:defRPr sz="750"/>
+              <a:defRPr sz="800"/>
             </a:lvl3pPr>
             <a:lvl4pPr marL="1028700" indent="0">
               <a:buNone/>
-              <a:defRPr sz="675"/>
+              <a:defRPr sz="800"/>
             </a:lvl4pPr>
             <a:lvl5pPr marL="1371600" indent="0">
               <a:buNone/>
-              <a:defRPr sz="675"/>
+              <a:defRPr sz="800"/>
             </a:lvl5pPr>
             <a:lvl6pPr marL="1714500" indent="0">
               <a:buNone/>
-              <a:defRPr sz="675"/>
+              <a:defRPr sz="800"/>
             </a:lvl6pPr>
             <a:lvl7pPr marL="2057400" indent="0">
               <a:buNone/>
-              <a:defRPr sz="675"/>
+              <a:defRPr sz="800"/>
             </a:lvl7pPr>
             <a:lvl8pPr marL="2400300" indent="0">
               <a:buNone/>
-              <a:defRPr sz="675"/>
+              <a:defRPr sz="800"/>
             </a:lvl8pPr>
             <a:lvl9pPr marL="2743200" indent="0">
               <a:buNone/>
-              <a:defRPr sz="675"/>
+              <a:defRPr sz="800"/>
             </a:lvl9pPr>
           </a:lstStyle>
           <a:p>
@@ -2803,7 +2803,7 @@
           <a:bodyPr anchor="ctr" bIns="45720" lIns="91440" rIns="91440" rtlCol="0" tIns="45720" vert="horz"/>
           <a:lstStyle>
             <a:lvl1pPr algn="l">
-              <a:defRPr sz="900">
+              <a:defRPr sz="800">
                 <a:solidFill>
                   <a:schemeClr val="tx1">
                     <a:tint val="75000"/>
@@ -2844,7 +2844,7 @@
           <a:bodyPr anchor="ctr" bIns="45720" lIns="91440" rIns="91440" rtlCol="0" tIns="45720" vert="horz"/>
           <a:lstStyle>
             <a:lvl1pPr algn="ctr">
-              <a:defRPr sz="900">
+              <a:defRPr sz="800">
                 <a:solidFill>
                   <a:schemeClr val="tx1">
                     <a:tint val="75000"/>
@@ -2881,7 +2881,7 @@
           <a:bodyPr anchor="ctr" bIns="45720" lIns="91440" rIns="91440" rtlCol="0" tIns="45720" vert="horz"/>
           <a:lstStyle>
             <a:lvl1pPr algn="r">
-              <a:defRPr sz="900">
+              <a:defRPr sz="800">
                 <a:solidFill>
                   <a:schemeClr val="tx1">
                     <a:tint val="75000"/>
@@ -2927,7 +2927,7 @@
           <a:spcPct val="0"/>
         </a:spcBef>
         <a:buNone/>
-        <a:defRPr kern="1200" sz="3300">
+        <a:defRPr kern="1200" sz="2310">
           <a:solidFill>
             <a:schemeClr val="tx1"/>
           </a:solidFill>
@@ -2944,7 +2944,7 @@
         </a:spcBef>
         <a:buFont typeface="Arial"/>
         <a:buChar char="•"/>
-        <a:defRPr kern="1200" sz="2400">
+        <a:defRPr kern="1200" sz="1680">
           <a:solidFill>
             <a:schemeClr val="tx1"/>
           </a:solidFill>
@@ -2959,7 +2959,7 @@
         </a:spcBef>
         <a:buFont typeface="Arial"/>
         <a:buChar char="–"/>
-        <a:defRPr kern="1200" sz="2100">
+        <a:defRPr kern="1200" sz="1470">
           <a:solidFill>
             <a:schemeClr val="tx1"/>
           </a:solidFill>
@@ -2974,7 +2974,7 @@
         </a:spcBef>
         <a:buFont typeface="Arial"/>
         <a:buChar char="•"/>
-        <a:defRPr kern="1200" sz="1800">
+        <a:defRPr kern="1200" sz="1260">
           <a:solidFill>
             <a:schemeClr val="tx1"/>
           </a:solidFill>
@@ -2989,7 +2989,7 @@
         </a:spcBef>
         <a:buFont typeface="Arial"/>
         <a:buChar char="–"/>
-        <a:defRPr kern="1200" sz="1500">
+        <a:defRPr kern="1200" sz="1050">
           <a:solidFill>
             <a:schemeClr val="tx1"/>
           </a:solidFill>
@@ -3004,7 +3004,7 @@
         </a:spcBef>
         <a:buFont typeface="Arial"/>
         <a:buChar char="»"/>
-        <a:defRPr kern="1200" sz="1500">
+        <a:defRPr kern="1200" sz="1050">
           <a:solidFill>
             <a:schemeClr val="tx1"/>
           </a:solidFill>
@@ -3019,7 +3019,7 @@
         </a:spcBef>
         <a:buFont typeface="Arial"/>
         <a:buChar char="•"/>
-        <a:defRPr kern="1200" sz="1500">
+        <a:defRPr kern="1200" sz="1050">
           <a:solidFill>
             <a:schemeClr val="tx1"/>
           </a:solidFill>
@@ -3034,7 +3034,7 @@
         </a:spcBef>
         <a:buFont typeface="Arial"/>
         <a:buChar char="•"/>
-        <a:defRPr kern="1200" sz="1500">
+        <a:defRPr kern="1200" sz="1050">
           <a:solidFill>
             <a:schemeClr val="tx1"/>
           </a:solidFill>
@@ -3049,7 +3049,7 @@
         </a:spcBef>
         <a:buFont typeface="Arial"/>
         <a:buChar char="•"/>
-        <a:defRPr kern="1200" sz="1500">
+        <a:defRPr kern="1200" sz="1050">
           <a:solidFill>
             <a:schemeClr val="tx1"/>
           </a:solidFill>
@@ -3064,7 +3064,7 @@
         </a:spcBef>
         <a:buFont typeface="Arial"/>
         <a:buChar char="•"/>
-        <a:defRPr kern="1200" sz="1500">
+        <a:defRPr kern="1200" sz="1050">
           <a:solidFill>
             <a:schemeClr val="tx1"/>
           </a:solidFill>
@@ -3079,7 +3079,7 @@
         <a:defRPr lang="en-US"/>
       </a:defPPr>
       <a:lvl1pPr algn="l" defTabSz="342900" eaLnBrk="1" hangingPunct="1" latinLnBrk="0" marL="0" rtl="0">
-        <a:defRPr kern="1200" sz="1350">
+        <a:defRPr kern="1200" sz="944">
           <a:solidFill>
             <a:schemeClr val="tx1"/>
           </a:solidFill>
@@ -3089,7 +3089,7 @@
         </a:defRPr>
       </a:lvl1pPr>
       <a:lvl2pPr algn="l" defTabSz="342900" eaLnBrk="1" hangingPunct="1" latinLnBrk="0" marL="342900" rtl="0">
-        <a:defRPr kern="1200" sz="1350">
+        <a:defRPr kern="1200" sz="944">
           <a:solidFill>
             <a:schemeClr val="tx1"/>
           </a:solidFill>
@@ -3099,7 +3099,7 @@
         </a:defRPr>
       </a:lvl2pPr>
       <a:lvl3pPr algn="l" defTabSz="342900" eaLnBrk="1" hangingPunct="1" latinLnBrk="0" marL="685800" rtl="0">
-        <a:defRPr kern="1200" sz="1350">
+        <a:defRPr kern="1200" sz="944">
           <a:solidFill>
             <a:schemeClr val="tx1"/>
           </a:solidFill>
@@ -3109,7 +3109,7 @@
         </a:defRPr>
       </a:lvl3pPr>
       <a:lvl4pPr algn="l" defTabSz="342900" eaLnBrk="1" hangingPunct="1" latinLnBrk="0" marL="1028700" rtl="0">
-        <a:defRPr kern="1200" sz="1350">
+        <a:defRPr kern="1200" sz="944">
           <a:solidFill>
             <a:schemeClr val="tx1"/>
           </a:solidFill>
@@ -3119,7 +3119,7 @@
         </a:defRPr>
       </a:lvl4pPr>
       <a:lvl5pPr algn="l" defTabSz="342900" eaLnBrk="1" hangingPunct="1" latinLnBrk="0" marL="1371600" rtl="0">
-        <a:defRPr kern="1200" sz="1350">
+        <a:defRPr kern="1200" sz="944">
           <a:solidFill>
             <a:schemeClr val="tx1"/>
           </a:solidFill>
@@ -3129,7 +3129,7 @@
         </a:defRPr>
       </a:lvl5pPr>
       <a:lvl6pPr algn="l" defTabSz="342900" eaLnBrk="1" hangingPunct="1" latinLnBrk="0" marL="1714500" rtl="0">
-        <a:defRPr kern="1200" sz="1350">
+        <a:defRPr kern="1200" sz="944">
           <a:solidFill>
             <a:schemeClr val="tx1"/>
           </a:solidFill>
@@ -3139,7 +3139,7 @@
         </a:defRPr>
       </a:lvl6pPr>
       <a:lvl7pPr algn="l" defTabSz="342900" eaLnBrk="1" hangingPunct="1" latinLnBrk="0" marL="2057400" rtl="0">
-        <a:defRPr kern="1200" sz="1350">
+        <a:defRPr kern="1200" sz="944">
           <a:solidFill>
             <a:schemeClr val="tx1"/>
           </a:solidFill>
@@ -3149,7 +3149,7 @@
         </a:defRPr>
       </a:lvl7pPr>
       <a:lvl8pPr algn="l" defTabSz="342900" eaLnBrk="1" hangingPunct="1" latinLnBrk="0" marL="2400300" rtl="0">
-        <a:defRPr kern="1200" sz="1350">
+        <a:defRPr kern="1200" sz="944">
           <a:solidFill>
             <a:schemeClr val="tx1"/>
           </a:solidFill>
@@ -3159,7 +3159,7 @@
         </a:defRPr>
       </a:lvl8pPr>
       <a:lvl9pPr algn="l" defTabSz="342900" eaLnBrk="1" hangingPunct="1" latinLnBrk="0" marL="2743200" rtl="0">
-        <a:defRPr kern="1200" sz="1350">
+        <a:defRPr kern="1200" sz="944">
           <a:solidFill>
             <a:schemeClr val="tx1"/>
           </a:solidFill>
@@ -26854,7 +26854,7 @@
       </a:bodyPr>
       <a:lstStyle>
         <a:defPPr algn="ctr">
-          <a:defRPr sz="1000" dirty="0" smtClean="0">
+          <a:defRPr sz="800" dirty="0" smtClean="0">
             <a:latin typeface="Arial" pitchFamily="34" charset="0"/>
             <a:cs typeface="Arial" pitchFamily="34" charset="0"/>
           </a:defRPr>

</xml_diff>

<commit_message>
Presentation: correct the matched-vs-full-cohort slide framing
Previous version overstated the case. The estimator-as-paired-estimand
framing is correct in general but misleading when applied to rescueCo:
under no effect modification and adequate overlap, full-cohort TMLE
and matched TMLE target the same marginal ATE.

New framing: gap is most plausibly sampling noise + the efficiency
cost of matching. The two would target different parameters only
under (a) effect modification by baseline covariates, or (b)
positivity strain. In rescueCo, PS is in [0.21, 0.81] and the gap
is within ~1 SE, so neither is obviously in play.

The prespecified primary remains the full-cohort TMLE because the
protocol question is about all eligible ambulance patients; the
matched-cohort row is now framed as a sensitivity check showing
that the answer is robust to the narrower target population, not
as a different estimand.
</commit_message>
<xml_diff>
--- a/reports/cleanTMLE_presentation.pptx
+++ b/reports/cleanTMLE_presentation.pptx
@@ -10019,64 +10019,31 @@
             </a:pPr>
             <a:r>
               <a:rPr/>
-              <a:t>Three things to read from this gap:</a:t>
-            </a:r>
-          </a:p>
-          <a:p>
-            <a:pPr lvl="0"/>
+              <a:t>Under standard assumptions (no effect modification by baseline covariates, adequate overlap), the matched and full-cohort estimators target the </a:t>
+            </a:r>
             <a:r>
               <a:rPr b="1"/>
-              <a:t>The matched estimates are about 0.5 to 1 percentage point smaller</a:t>
-            </a:r>
-            <a:r>
-              <a:rPr/>
-              <a:t> than the full-cohort estimates.</a:t>
-            </a:r>
-          </a:p>
-          <a:p>
-            <a:pPr lvl="0"/>
+              <a:t>same</a:t>
+            </a:r>
+            <a:r>
+              <a:rPr/>
+              <a:t> marginal treatment effect and should agree in expectation. The 0.005 to 0.011 gap here is most plausibly </a:t>
+            </a:r>
             <a:r>
               <a:rPr b="1"/>
-              <a:t>The matched confidence intervals are roughly 50 % wider</a:t>
-            </a:r>
-            <a:r>
-              <a:rPr/>
-              <a:t>, because matching throws away patients outside the overlap region.</a:t>
-            </a:r>
-          </a:p>
-          <a:p>
-            <a:pPr lvl="0"/>
+              <a:t>sampling noise</a:t>
+            </a:r>
+            <a:r>
+              <a:rPr/>
+              <a:t>, with the matched confidence intervals roughly 50 % wider because matching throws away controls (which is also an </a:t>
+            </a:r>
             <a:r>
               <a:rPr b="1"/>
-              <a:t>The matched and full-cohort estimators are not estimates of the same quantity.</a:t>
-            </a:r>
-            <a:r>
-              <a:rPr/>
-              <a:t> Matched estimators target the average effect </a:t>
-            </a:r>
-            <a:r>
-              <a:rPr i="1"/>
-              <a:t>in the matched overlap subset</a:t>
-            </a:r>
-            <a:r>
-              <a:rPr/>
-              <a:t>; full-cohort estimators target the average effect </a:t>
-            </a:r>
-            <a:r>
-              <a:rPr i="1"/>
-              <a:t>in the full eligible cohort</a:t>
-            </a:r>
-            <a:r>
-              <a:rPr/>
-              <a:t>. When overlap is partial, these two target populations differ and the estimates </a:t>
-            </a:r>
-            <a:r>
-              <a:rPr i="1"/>
-              <a:t>should</a:t>
-            </a:r>
-            <a:r>
-              <a:rPr/>
-              <a:t> differ. Whether matched or full-cohort is the right primary depends on which population the study question is about.</a:t>
+              <a:t>efficiency cost</a:t>
+            </a:r>
+            <a:r>
+              <a:rPr/>
+              <a:t>, not a bias signal).</a:t>
             </a:r>
           </a:p>
           <a:p>
@@ -10085,7 +10052,46 @@
             </a:pPr>
             <a:r>
               <a:rPr/>
-              <a:t>In this case study the prespecified primary is the full-cohort TMLE, because the protocol question is about all eligible ambulance patients, not only those whose baseline profile makes them comparable. The matched-cohort row is reported as a sensitivity analysis on a narrower target population.</a:t>
+              <a:t>They would target </a:t>
+            </a:r>
+            <a:r>
+              <a:rPr i="1"/>
+              <a:t>different</a:t>
+            </a:r>
+            <a:r>
+              <a:rPr/>
+              <a:t> causal parameters in two specific situations:</a:t>
+            </a:r>
+          </a:p>
+          <a:p>
+            <a:pPr lvl="0"/>
+            <a:r>
+              <a:rPr b="1"/>
+              <a:t>Effect modification by baseline covariates.</a:t>
+            </a:r>
+            <a:r>
+              <a:rPr/>
+              <a:t> If the Rescue.Co effect were genuinely different in the overlap subset than in the full cohort, the two estimators would converge to different numbers in expectation.</a:t>
+            </a:r>
+          </a:p>
+          <a:p>
+            <a:pPr lvl="0"/>
+            <a:r>
+              <a:rPr b="1"/>
+              <a:t>Positivity strain.</a:t>
+            </a:r>
+            <a:r>
+              <a:rPr/>
+              <a:t> If propensity scores for some patients were near 0 or 1, the marginal full-cohort ATE would not be identifiable without model-based extrapolation, and the matched estimator would be the more conservative target.</a:t>
+            </a:r>
+          </a:p>
+          <a:p>
+            <a:pPr lvl="0" indent="0" marL="0">
+              <a:buNone/>
+            </a:pPr>
+            <a:r>
+              <a:rPr/>
+              <a:t>In rescueCo, propensity scores stayed inside [0.21, 0.81] and the gap is within roughly one standard error of each estimate, so the most parsimonious reading is sampling noise plus the efficiency cost of matching. The prespecified primary is the full-cohort TMLE because the protocol question is about all eligible ambulance patients; the matched-cohort row is a sensitivity analysis showing the answer is robust to the narrower target population.</a:t>
             </a:r>
           </a:p>
         </p:txBody>

</xml_diff>